<commit_message>
fix: regenerate Session 2 PPT files with correct paths
- Update generate_ppt.py and generate_ppt_ja.py with VibeCoding_Workshop paths
- Regenerate Session2_VibeCoding.pptx (Chinese, 51 slides)
- Regenerate Session2_VibeCoding_JA.pptx (Japanese, 51 slides)
</commit_message>
<xml_diff>
--- a/session2/slides/Session2_VibeCoding.pptx
+++ b/session2/slides/Session2_VibeCoding.pptx
@@ -46,6 +46,16 @@
     <p:sldId id="294" r:id="rId46"/>
     <p:sldId id="295" r:id="rId47"/>
     <p:sldId id="296" r:id="rId48"/>
+    <p:sldId id="297" r:id="rId49"/>
+    <p:sldId id="298" r:id="rId50"/>
+    <p:sldId id="299" r:id="rId51"/>
+    <p:sldId id="300" r:id="rId52"/>
+    <p:sldId id="301" r:id="rId53"/>
+    <p:sldId id="302" r:id="rId54"/>
+    <p:sldId id="303" r:id="rId55"/>
+    <p:sldId id="304" r:id="rId56"/>
+    <p:sldId id="305" r:id="rId57"/>
+    <p:sldId id="306" r:id="rId58"/>
   </p:sldIdLst>
   <p:sldSz cx="12191695" cy="6858000" type="screen4x3"/>
   <p:notesSz cx="6858000" cy="9144000"/>
@@ -2582,6 +2592,441 @@
 </p:notes>
 </file>
 
+<file path=ppt/notesSlides/notesSlide34.xml><?xml version="1.0" encoding="utf-8"?>
+<p:notes xmlns:a="http://schemas.openxmlformats.org/drawingml/2006/main" xmlns:p="http://schemas.openxmlformats.org/presentationml/2006/main" xmlns:r="http://schemas.openxmlformats.org/officeDocument/2006/relationships">
+  <p:cSld>
+    <p:spTree>
+      <p:nvGrpSpPr>
+        <p:cNvPr id="1" name=""/>
+        <p:cNvGrpSpPr/>
+        <p:nvPr/>
+      </p:nvGrpSpPr>
+      <p:grpSpPr>
+        <a:xfrm>
+          <a:off x="0" y="0"/>
+          <a:ext cx="0" cy="0"/>
+          <a:chOff x="0" y="0"/>
+          <a:chExt cx="0" cy="0"/>
+        </a:xfrm>
+      </p:grpSpPr>
+      <p:sp>
+        <p:nvSpPr>
+          <p:cNvPr id="2" name="Slide Image Placeholder 1"/>
+          <p:cNvSpPr>
+            <a:spLocks noGrp="1"/>
+          </p:cNvSpPr>
+          <p:nvPr>
+            <p:ph type="sldImg" idx="2"/>
+          </p:nvPr>
+        </p:nvSpPr>
+        <p:spPr/>
+      </p:sp>
+      <p:sp>
+        <p:nvSpPr>
+          <p:cNvPr id="3" name="Notes Placeholder 2"/>
+          <p:cNvSpPr>
+            <a:spLocks noGrp="1"/>
+          </p:cNvSpPr>
+          <p:nvPr>
+            <p:ph type="body" idx="3" sz="quarter"/>
+          </p:nvPr>
+        </p:nvSpPr>
+        <p:spPr/>
+        <p:txBody>
+          <a:bodyPr/>
+          <a:lstStyle/>
+          <a:p>
+            <a:r>
+              <a:t>連結到之前的 API 概念。「你記得我們剛才玩的狗狗 API 嗎？給它一個請求，它給你一張狗圖。LLM 其實也是一樣的概念——你給它問題，它給你答案。只是答案是 AI 生成的文字。」</a:t>
+            </a:r>
+          </a:p>
+        </p:txBody>
+      </p:sp>
+      <p:sp>
+        <p:nvSpPr>
+          <p:cNvPr id="4" name="Slide Number Placeholder 3"/>
+          <p:cNvSpPr>
+            <a:spLocks noGrp="1"/>
+          </p:cNvSpPr>
+          <p:nvPr>
+            <p:ph type="sldNum" idx="5" sz="quarter"/>
+          </p:nvPr>
+        </p:nvSpPr>
+        <p:spPr/>
+      </p:sp>
+    </p:spTree>
+  </p:cSld>
+  <p:clrMapOvr>
+    <a:masterClrMapping/>
+  </p:clrMapOvr>
+</p:notes>
+</file>
+
+<file path=ppt/notesSlides/notesSlide35.xml><?xml version="1.0" encoding="utf-8"?>
+<p:notes xmlns:a="http://schemas.openxmlformats.org/drawingml/2006/main" xmlns:p="http://schemas.openxmlformats.org/presentationml/2006/main" xmlns:r="http://schemas.openxmlformats.org/officeDocument/2006/relationships">
+  <p:cSld>
+    <p:spTree>
+      <p:nvGrpSpPr>
+        <p:cNvPr id="1" name=""/>
+        <p:cNvGrpSpPr/>
+        <p:nvPr/>
+      </p:nvGrpSpPr>
+      <p:grpSpPr>
+        <a:xfrm>
+          <a:off x="0" y="0"/>
+          <a:ext cx="0" cy="0"/>
+          <a:chOff x="0" y="0"/>
+          <a:chExt cx="0" cy="0"/>
+        </a:xfrm>
+      </p:grpSpPr>
+      <p:sp>
+        <p:nvSpPr>
+          <p:cNvPr id="2" name="Slide Image Placeholder 1"/>
+          <p:cNvSpPr>
+            <a:spLocks noGrp="1"/>
+          </p:cNvSpPr>
+          <p:nvPr>
+            <p:ph type="sldImg" idx="2"/>
+          </p:nvPr>
+        </p:nvSpPr>
+        <p:spPr/>
+      </p:sp>
+      <p:sp>
+        <p:nvSpPr>
+          <p:cNvPr id="3" name="Notes Placeholder 2"/>
+          <p:cNvSpPr>
+            <a:spLocks noGrp="1"/>
+          </p:cNvSpPr>
+          <p:nvPr>
+            <p:ph type="body" idx="3" sz="quarter"/>
+          </p:nvPr>
+        </p:nvSpPr>
+        <p:spPr/>
+        <p:txBody>
+          <a:bodyPr/>
+          <a:lstStyle/>
+          <a:p>
+            <a:r>
+              <a:t>這步驟讓她自己操作。「我們先去 Google AI Studio 玩一下。這是 Google 提供的 AI 實驗室，可以免費試用 Gemini 模型。」</a:t>
+            </a:r>
+          </a:p>
+          <a:p>
+            <a:r>
+              <a:t>讓她隨便問幾個問題，感受一下 AI 的回答。</a:t>
+            </a:r>
+          </a:p>
+        </p:txBody>
+      </p:sp>
+      <p:sp>
+        <p:nvSpPr>
+          <p:cNvPr id="4" name="Slide Number Placeholder 3"/>
+          <p:cNvSpPr>
+            <a:spLocks noGrp="1"/>
+          </p:cNvSpPr>
+          <p:nvPr>
+            <p:ph type="sldNum" idx="5" sz="quarter"/>
+          </p:nvPr>
+        </p:nvSpPr>
+        <p:spPr/>
+      </p:sp>
+    </p:spTree>
+  </p:cSld>
+  <p:clrMapOvr>
+    <a:masterClrMapping/>
+  </p:clrMapOvr>
+</p:notes>
+</file>
+
+<file path=ppt/notesSlides/notesSlide36.xml><?xml version="1.0" encoding="utf-8"?>
+<p:notes xmlns:a="http://schemas.openxmlformats.org/drawingml/2006/main" xmlns:p="http://schemas.openxmlformats.org/presentationml/2006/main" xmlns:r="http://schemas.openxmlformats.org/officeDocument/2006/relationships">
+  <p:cSld>
+    <p:spTree>
+      <p:nvGrpSpPr>
+        <p:cNvPr id="1" name=""/>
+        <p:cNvGrpSpPr/>
+        <p:nvPr/>
+      </p:nvGrpSpPr>
+      <p:grpSpPr>
+        <a:xfrm>
+          <a:off x="0" y="0"/>
+          <a:ext cx="0" cy="0"/>
+          <a:chOff x="0" y="0"/>
+          <a:chExt cx="0" cy="0"/>
+        </a:xfrm>
+      </p:grpSpPr>
+      <p:sp>
+        <p:nvSpPr>
+          <p:cNvPr id="2" name="Slide Image Placeholder 1"/>
+          <p:cNvSpPr>
+            <a:spLocks noGrp="1"/>
+          </p:cNvSpPr>
+          <p:nvPr>
+            <p:ph type="sldImg" idx="2"/>
+          </p:nvPr>
+        </p:nvSpPr>
+        <p:spPr/>
+      </p:sp>
+      <p:sp>
+        <p:nvSpPr>
+          <p:cNvPr id="3" name="Notes Placeholder 2"/>
+          <p:cNvSpPr>
+            <a:spLocks noGrp="1"/>
+          </p:cNvSpPr>
+          <p:nvPr>
+            <p:ph type="body" idx="3" sz="quarter"/>
+          </p:nvPr>
+        </p:nvSpPr>
+        <p:spPr/>
+        <p:txBody>
+          <a:bodyPr/>
+          <a:lstStyle/>
+          <a:p>
+            <a:r>
+              <a:t>「API Key 就像你家的鑰匙，有這把鑰匙就能進門。Google 會根據這把鑰匙來計算你用了多少資源。所以一定要保護好，不要隨便分享。」</a:t>
+            </a:r>
+          </a:p>
+        </p:txBody>
+      </p:sp>
+      <p:sp>
+        <p:nvSpPr>
+          <p:cNvPr id="4" name="Slide Number Placeholder 3"/>
+          <p:cNvSpPr>
+            <a:spLocks noGrp="1"/>
+          </p:cNvSpPr>
+          <p:nvPr>
+            <p:ph type="sldNum" idx="5" sz="quarter"/>
+          </p:nvPr>
+        </p:nvSpPr>
+        <p:spPr/>
+      </p:sp>
+    </p:spTree>
+  </p:cSld>
+  <p:clrMapOvr>
+    <a:masterClrMapping/>
+  </p:clrMapOvr>
+</p:notes>
+</file>
+
+<file path=ppt/notesSlides/notesSlide37.xml><?xml version="1.0" encoding="utf-8"?>
+<p:notes xmlns:a="http://schemas.openxmlformats.org/drawingml/2006/main" xmlns:p="http://schemas.openxmlformats.org/presentationml/2006/main" xmlns:r="http://schemas.openxmlformats.org/officeDocument/2006/relationships">
+  <p:cSld>
+    <p:spTree>
+      <p:nvGrpSpPr>
+        <p:cNvPr id="1" name=""/>
+        <p:cNvGrpSpPr/>
+        <p:nvPr/>
+      </p:nvGrpSpPr>
+      <p:grpSpPr>
+        <a:xfrm>
+          <a:off x="0" y="0"/>
+          <a:ext cx="0" cy="0"/>
+          <a:chOff x="0" y="0"/>
+          <a:chExt cx="0" cy="0"/>
+        </a:xfrm>
+      </p:grpSpPr>
+      <p:sp>
+        <p:nvSpPr>
+          <p:cNvPr id="2" name="Slide Image Placeholder 1"/>
+          <p:cNvSpPr>
+            <a:spLocks noGrp="1"/>
+          </p:cNvSpPr>
+          <p:nvPr>
+            <p:ph type="sldImg" idx="2"/>
+          </p:nvPr>
+        </p:nvSpPr>
+        <p:spPr/>
+      </p:sp>
+      <p:sp>
+        <p:nvSpPr>
+          <p:cNvPr id="3" name="Notes Placeholder 2"/>
+          <p:cNvSpPr>
+            <a:spLocks noGrp="1"/>
+          </p:cNvSpPr>
+          <p:nvPr>
+            <p:ph type="body" idx="3" sz="quarter"/>
+          </p:nvPr>
+        </p:nvSpPr>
+        <p:spPr/>
+        <p:txBody>
+          <a:bodyPr/>
+          <a:lstStyle/>
+          <a:p>
+            <a:r>
+              <a:t>「這跟我們之前用 curl 測試狗狗 API 是一樣的概念。只是現在我們打的是 Google Gemini 的 API。」</a:t>
+            </a:r>
+          </a:p>
+          <a:p>
+            <a:r>
+              <a:t>她可能需要幫忙把 API Key 貼上去。注意引號要用英文的。</a:t>
+            </a:r>
+          </a:p>
+          <a:p>
+            <a:r>
+              <a:t>如果成功，會看到一大串 JSON，裡面有 AI 的回答。</a:t>
+            </a:r>
+          </a:p>
+        </p:txBody>
+      </p:sp>
+      <p:sp>
+        <p:nvSpPr>
+          <p:cNvPr id="4" name="Slide Number Placeholder 3"/>
+          <p:cNvSpPr>
+            <a:spLocks noGrp="1"/>
+          </p:cNvSpPr>
+          <p:nvPr>
+            <p:ph type="sldNum" idx="5" sz="quarter"/>
+          </p:nvPr>
+        </p:nvSpPr>
+        <p:spPr/>
+      </p:sp>
+    </p:spTree>
+  </p:cSld>
+  <p:clrMapOvr>
+    <a:masterClrMapping/>
+  </p:clrMapOvr>
+</p:notes>
+</file>
+
+<file path=ppt/notesSlides/notesSlide38.xml><?xml version="1.0" encoding="utf-8"?>
+<p:notes xmlns:a="http://schemas.openxmlformats.org/drawingml/2006/main" xmlns:p="http://schemas.openxmlformats.org/presentationml/2006/main" xmlns:r="http://schemas.openxmlformats.org/officeDocument/2006/relationships">
+  <p:cSld>
+    <p:spTree>
+      <p:nvGrpSpPr>
+        <p:cNvPr id="1" name=""/>
+        <p:cNvGrpSpPr/>
+        <p:nvPr/>
+      </p:nvGrpSpPr>
+      <p:grpSpPr>
+        <a:xfrm>
+          <a:off x="0" y="0"/>
+          <a:ext cx="0" cy="0"/>
+          <a:chOff x="0" y="0"/>
+          <a:chExt cx="0" cy="0"/>
+        </a:xfrm>
+      </p:grpSpPr>
+      <p:sp>
+        <p:nvSpPr>
+          <p:cNvPr id="2" name="Slide Image Placeholder 1"/>
+          <p:cNvSpPr>
+            <a:spLocks noGrp="1"/>
+          </p:cNvSpPr>
+          <p:nvPr>
+            <p:ph type="sldImg" idx="2"/>
+          </p:nvPr>
+        </p:nvSpPr>
+        <p:spPr/>
+      </p:sp>
+      <p:sp>
+        <p:nvSpPr>
+          <p:cNvPr id="3" name="Notes Placeholder 2"/>
+          <p:cNvSpPr>
+            <a:spLocks noGrp="1"/>
+          </p:cNvSpPr>
+          <p:nvPr>
+            <p:ph type="body" idx="3" sz="quarter"/>
+          </p:nvPr>
+        </p:nvSpPr>
+        <p:spPr/>
+        <p:txBody>
+          <a:bodyPr/>
+          <a:lstStyle/>
+          <a:p>
+            <a:r>
+              <a:t>這是安全觀念的建立。「如果你直接把 API Key 放在網頁的 JavaScript 裡，任何人按 F12 打開開發者工具都能看到。所以我們需要一個中間人來幫我們藏 Key。」</a:t>
+            </a:r>
+          </a:p>
+        </p:txBody>
+      </p:sp>
+      <p:sp>
+        <p:nvSpPr>
+          <p:cNvPr id="4" name="Slide Number Placeholder 3"/>
+          <p:cNvSpPr>
+            <a:spLocks noGrp="1"/>
+          </p:cNvSpPr>
+          <p:nvPr>
+            <p:ph type="sldNum" idx="5" sz="quarter"/>
+          </p:nvPr>
+        </p:nvSpPr>
+        <p:spPr/>
+      </p:sp>
+    </p:spTree>
+  </p:cSld>
+  <p:clrMapOvr>
+    <a:masterClrMapping/>
+  </p:clrMapOvr>
+</p:notes>
+</file>
+
+<file path=ppt/notesSlides/notesSlide39.xml><?xml version="1.0" encoding="utf-8"?>
+<p:notes xmlns:a="http://schemas.openxmlformats.org/drawingml/2006/main" xmlns:p="http://schemas.openxmlformats.org/presentationml/2006/main" xmlns:r="http://schemas.openxmlformats.org/officeDocument/2006/relationships">
+  <p:cSld>
+    <p:spTree>
+      <p:nvGrpSpPr>
+        <p:cNvPr id="1" name=""/>
+        <p:cNvGrpSpPr/>
+        <p:nvPr/>
+      </p:nvGrpSpPr>
+      <p:grpSpPr>
+        <a:xfrm>
+          <a:off x="0" y="0"/>
+          <a:ext cx="0" cy="0"/>
+          <a:chOff x="0" y="0"/>
+          <a:chExt cx="0" cy="0"/>
+        </a:xfrm>
+      </p:grpSpPr>
+      <p:sp>
+        <p:nvSpPr>
+          <p:cNvPr id="2" name="Slide Image Placeholder 1"/>
+          <p:cNvSpPr>
+            <a:spLocks noGrp="1"/>
+          </p:cNvSpPr>
+          <p:nvPr>
+            <p:ph type="sldImg" idx="2"/>
+          </p:nvPr>
+        </p:nvSpPr>
+        <p:spPr/>
+      </p:sp>
+      <p:sp>
+        <p:nvSpPr>
+          <p:cNvPr id="3" name="Notes Placeholder 2"/>
+          <p:cNvSpPr>
+            <a:spLocks noGrp="1"/>
+          </p:cNvSpPr>
+          <p:nvPr>
+            <p:ph type="body" idx="3" sz="quarter"/>
+          </p:nvPr>
+        </p:nvSpPr>
+        <p:spPr/>
+        <p:txBody>
+          <a:bodyPr/>
+          <a:lstStyle/>
+          <a:p>
+            <a:r>
+              <a:t>這步驟可以讓她自己操作，你在旁邊指導。「Cloudflare 是一家很大的網路公司，他們提供免費的 Worker 服務。我們可以把代碼放在他們的伺服器上運行。」</a:t>
+            </a:r>
+          </a:p>
+        </p:txBody>
+      </p:sp>
+      <p:sp>
+        <p:nvSpPr>
+          <p:cNvPr id="4" name="Slide Number Placeholder 3"/>
+          <p:cNvSpPr>
+            <a:spLocks noGrp="1"/>
+          </p:cNvSpPr>
+          <p:nvPr>
+            <p:ph type="sldNum" idx="5" sz="quarter"/>
+          </p:nvPr>
+        </p:nvSpPr>
+        <p:spPr/>
+      </p:sp>
+    </p:spTree>
+  </p:cSld>
+  <p:clrMapOvr>
+    <a:masterClrMapping/>
+  </p:clrMapOvr>
+</p:notes>
+</file>
+
 <file path=ppt/notesSlides/notesSlide4.xml><?xml version="1.0" encoding="utf-8"?>
 <p:notes xmlns:a="http://schemas.openxmlformats.org/drawingml/2006/main" xmlns:p="http://schemas.openxmlformats.org/presentationml/2006/main" xmlns:r="http://schemas.openxmlformats.org/officeDocument/2006/relationships">
   <p:cSld>
@@ -2633,6 +3078,216 @@
           <a:p>
             <a:r>
               <a:t>關鍵句：「你現在做的網站就像一個超美的快閃店——佈置精美，但沒有收銀機。動態網站就是加上收銀機和會員系統。但先不急。」</a:t>
+            </a:r>
+          </a:p>
+        </p:txBody>
+      </p:sp>
+      <p:sp>
+        <p:nvSpPr>
+          <p:cNvPr id="4" name="Slide Number Placeholder 3"/>
+          <p:cNvSpPr>
+            <a:spLocks noGrp="1"/>
+          </p:cNvSpPr>
+          <p:nvPr>
+            <p:ph type="sldNum" idx="5" sz="quarter"/>
+          </p:nvPr>
+        </p:nvSpPr>
+        <p:spPr/>
+      </p:sp>
+    </p:spTree>
+  </p:cSld>
+  <p:clrMapOvr>
+    <a:masterClrMapping/>
+  </p:clrMapOvr>
+</p:notes>
+</file>
+
+<file path=ppt/notesSlides/notesSlide40.xml><?xml version="1.0" encoding="utf-8"?>
+<p:notes xmlns:a="http://schemas.openxmlformats.org/drawingml/2006/main" xmlns:p="http://schemas.openxmlformats.org/presentationml/2006/main" xmlns:r="http://schemas.openxmlformats.org/officeDocument/2006/relationships">
+  <p:cSld>
+    <p:spTree>
+      <p:nvGrpSpPr>
+        <p:cNvPr id="1" name=""/>
+        <p:cNvGrpSpPr/>
+        <p:nvPr/>
+      </p:nvGrpSpPr>
+      <p:grpSpPr>
+        <a:xfrm>
+          <a:off x="0" y="0"/>
+          <a:ext cx="0" cy="0"/>
+          <a:chOff x="0" y="0"/>
+          <a:chExt cx="0" cy="0"/>
+        </a:xfrm>
+      </p:grpSpPr>
+      <p:sp>
+        <p:nvSpPr>
+          <p:cNvPr id="2" name="Slide Image Placeholder 1"/>
+          <p:cNvSpPr>
+            <a:spLocks noGrp="1"/>
+          </p:cNvSpPr>
+          <p:nvPr>
+            <p:ph type="sldImg" idx="2"/>
+          </p:nvPr>
+        </p:nvSpPr>
+        <p:spPr/>
+      </p:sp>
+      <p:sp>
+        <p:nvSpPr>
+          <p:cNvPr id="3" name="Notes Placeholder 2"/>
+          <p:cNvSpPr>
+            <a:spLocks noGrp="1"/>
+          </p:cNvSpPr>
+          <p:nvPr>
+            <p:ph type="body" idx="3" sz="quarter"/>
+          </p:nvPr>
+        </p:nvSpPr>
+        <p:spPr/>
+        <p:txBody>
+          <a:bodyPr/>
+          <a:lstStyle/>
+          <a:p>
+            <a:r>
+              <a:t>這段代碼可以讓她的 AI 幫忙生成，或直接複製貼上。重點是讓她理解「這段代碼會接收網頁的請求，然後幫你去問 Google AI，再把答案傳回來」。</a:t>
+            </a:r>
+          </a:p>
+        </p:txBody>
+      </p:sp>
+      <p:sp>
+        <p:nvSpPr>
+          <p:cNvPr id="4" name="Slide Number Placeholder 3"/>
+          <p:cNvSpPr>
+            <a:spLocks noGrp="1"/>
+          </p:cNvSpPr>
+          <p:nvPr>
+            <p:ph type="sldNum" idx="5" sz="quarter"/>
+          </p:nvPr>
+        </p:nvSpPr>
+        <p:spPr/>
+      </p:sp>
+    </p:spTree>
+  </p:cSld>
+  <p:clrMapOvr>
+    <a:masterClrMapping/>
+  </p:clrMapOvr>
+</p:notes>
+</file>
+
+<file path=ppt/notesSlides/notesSlide41.xml><?xml version="1.0" encoding="utf-8"?>
+<p:notes xmlns:a="http://schemas.openxmlformats.org/drawingml/2006/main" xmlns:p="http://schemas.openxmlformats.org/presentationml/2006/main" xmlns:r="http://schemas.openxmlformats.org/officeDocument/2006/relationships">
+  <p:cSld>
+    <p:spTree>
+      <p:nvGrpSpPr>
+        <p:cNvPr id="1" name=""/>
+        <p:cNvGrpSpPr/>
+        <p:nvPr/>
+      </p:nvGrpSpPr>
+      <p:grpSpPr>
+        <a:xfrm>
+          <a:off x="0" y="0"/>
+          <a:ext cx="0" cy="0"/>
+          <a:chOff x="0" y="0"/>
+          <a:chExt cx="0" cy="0"/>
+        </a:xfrm>
+      </p:grpSpPr>
+      <p:sp>
+        <p:nvSpPr>
+          <p:cNvPr id="2" name="Slide Image Placeholder 1"/>
+          <p:cNvSpPr>
+            <a:spLocks noGrp="1"/>
+          </p:cNvSpPr>
+          <p:nvPr>
+            <p:ph type="sldImg" idx="2"/>
+          </p:nvPr>
+        </p:nvSpPr>
+        <p:spPr/>
+      </p:sp>
+      <p:sp>
+        <p:nvSpPr>
+          <p:cNvPr id="3" name="Notes Placeholder 2"/>
+          <p:cNvSpPr>
+            <a:spLocks noGrp="1"/>
+          </p:cNvSpPr>
+          <p:nvPr>
+            <p:ph type="body" idx="3" sz="quarter"/>
+          </p:nvPr>
+        </p:nvSpPr>
+        <p:spPr/>
+        <p:txBody>
+          <a:bodyPr/>
+          <a:lstStyle/>
+          <a:p>
+            <a:r>
+              <a:t>「Secret 就是秘密變數的意思。我們把 API Key 存在這裡，代碼裡用 env.GEMINI_API_KEY 就能讀到，但外面的人看不到實際的值。」</a:t>
+            </a:r>
+          </a:p>
+        </p:txBody>
+      </p:sp>
+      <p:sp>
+        <p:nvSpPr>
+          <p:cNvPr id="4" name="Slide Number Placeholder 3"/>
+          <p:cNvSpPr>
+            <a:spLocks noGrp="1"/>
+          </p:cNvSpPr>
+          <p:nvPr>
+            <p:ph type="sldNum" idx="5" sz="quarter"/>
+          </p:nvPr>
+        </p:nvSpPr>
+        <p:spPr/>
+      </p:sp>
+    </p:spTree>
+  </p:cSld>
+  <p:clrMapOvr>
+    <a:masterClrMapping/>
+  </p:clrMapOvr>
+</p:notes>
+</file>
+
+<file path=ppt/notesSlides/notesSlide42.xml><?xml version="1.0" encoding="utf-8"?>
+<p:notes xmlns:a="http://schemas.openxmlformats.org/drawingml/2006/main" xmlns:p="http://schemas.openxmlformats.org/presentationml/2006/main" xmlns:r="http://schemas.openxmlformats.org/officeDocument/2006/relationships">
+  <p:cSld>
+    <p:spTree>
+      <p:nvGrpSpPr>
+        <p:cNvPr id="1" name=""/>
+        <p:cNvGrpSpPr/>
+        <p:nvPr/>
+      </p:nvGrpSpPr>
+      <p:grpSpPr>
+        <a:xfrm>
+          <a:off x="0" y="0"/>
+          <a:ext cx="0" cy="0"/>
+          <a:chOff x="0" y="0"/>
+          <a:chExt cx="0" cy="0"/>
+        </a:xfrm>
+      </p:grpSpPr>
+      <p:sp>
+        <p:nvSpPr>
+          <p:cNvPr id="2" name="Slide Image Placeholder 1"/>
+          <p:cNvSpPr>
+            <a:spLocks noGrp="1"/>
+          </p:cNvSpPr>
+          <p:nvPr>
+            <p:ph type="sldImg" idx="2"/>
+          </p:nvPr>
+        </p:nvSpPr>
+        <p:spPr/>
+      </p:sp>
+      <p:sp>
+        <p:nvSpPr>
+          <p:cNvPr id="3" name="Notes Placeholder 2"/>
+          <p:cNvSpPr>
+            <a:spLocks noGrp="1"/>
+          </p:cNvSpPr>
+          <p:nvPr>
+            <p:ph type="body" idx="3" sz="quarter"/>
+          </p:nvPr>
+        </p:nvSpPr>
+        <p:spPr/>
+        <p:txBody>
+          <a:bodyPr/>
+          <a:lstStyle/>
+          <a:p>
+            <a:r>
+              <a:t>這是成就感的高峰！「恭喜你！你現在有了一個只屬於你的 AI API。之後你可以在任何網頁裡呼叫這個網址，讓你的網站也能用 AI 回答問題。」</a:t>
             </a:r>
           </a:p>
         </p:txBody>
@@ -10626,7 +11281,7 @@
     <p:bg>
       <p:bgPr>
         <a:solidFill>
-          <a:srgbClr val="441133"/>
+          <a:srgbClr val="1A1A2E"/>
         </a:solidFill>
         <a:effectLst/>
       </p:bgPr>
@@ -10668,7 +11323,917 @@
               </a:defRPr>
             </a:pPr>
             <a:r>
-              <a:t>📝 附錄：Jones 的教學備忘</a:t>
+              <a:t>Block 7 ▸ 進階：LLM API 實戰</a:t>
+            </a:r>
+          </a:p>
+        </p:txBody>
+      </p:sp>
+    </p:spTree>
+  </p:cSld>
+  <p:clrMapOvr>
+    <a:masterClrMapping/>
+  </p:clrMapOvr>
+</p:sld>
+</file>
+
+<file path=ppt/slides/slide42.xml><?xml version="1.0" encoding="utf-8"?>
+<p:sld xmlns:a="http://schemas.openxmlformats.org/drawingml/2006/main" xmlns:p="http://schemas.openxmlformats.org/presentationml/2006/main" xmlns:r="http://schemas.openxmlformats.org/officeDocument/2006/relationships">
+  <p:cSld>
+    <p:bg>
+      <p:bgPr>
+        <a:solidFill>
+          <a:srgbClr val="1A1A2E"/>
+        </a:solidFill>
+        <a:effectLst/>
+      </p:bgPr>
+    </p:bg>
+    <p:spTree>
+      <p:nvGrpSpPr>
+        <p:cNvPr id="1" name=""/>
+        <p:cNvGrpSpPr/>
+        <p:nvPr/>
+      </p:nvGrpSpPr>
+      <p:grpSpPr/>
+      <p:sp>
+        <p:nvSpPr>
+          <p:cNvPr id="2" name="TextBox 1"/>
+          <p:cNvSpPr txBox="1"/>
+          <p:nvPr/>
+        </p:nvSpPr>
+        <p:spPr>
+          <a:xfrm>
+            <a:off x="731520" y="365760"/>
+            <a:ext cx="10058400" cy="914400"/>
+          </a:xfrm>
+          <a:prstGeom prst="rect">
+            <a:avLst/>
+          </a:prstGeom>
+          <a:noFill/>
+        </p:spPr>
+        <p:txBody>
+          <a:bodyPr wrap="square">
+            <a:spAutoFit/>
+          </a:bodyPr>
+          <a:lstStyle/>
+          <a:p>
+            <a:pPr algn="l">
+              <a:defRPr sz="3200" b="1">
+                <a:solidFill>
+                  <a:srgbClr val="FFE135"/>
+                </a:solidFill>
+              </a:defRPr>
+            </a:pPr>
+            <a:r>
+              <a:t>原來 ChatGPT / Gemini 也是 API</a:t>
+            </a:r>
+          </a:p>
+        </p:txBody>
+      </p:sp>
+      <p:sp>
+        <p:nvSpPr>
+          <p:cNvPr id="3" name="TextBox 2"/>
+          <p:cNvSpPr txBox="1"/>
+          <p:nvPr/>
+        </p:nvSpPr>
+        <p:spPr>
+          <a:xfrm>
+            <a:off x="731520" y="1828800"/>
+            <a:ext cx="10058400" cy="3657600"/>
+          </a:xfrm>
+          <a:prstGeom prst="rect">
+            <a:avLst/>
+          </a:prstGeom>
+          <a:solidFill>
+            <a:srgbClr val="0D0D0D"/>
+          </a:solidFill>
+        </p:spPr>
+        <p:txBody>
+          <a:bodyPr wrap="square">
+            <a:spAutoFit/>
+          </a:bodyPr>
+          <a:lstStyle/>
+          <a:p>
+            <a:pPr>
+              <a:defRPr sz="1400">
+                <a:solidFill>
+                  <a:srgbClr val="00FF88"/>
+                </a:solidFill>
+                <a:latin typeface="Menlo"/>
+              </a:defRPr>
+            </a:pPr>
+            <a:r>
+              <a:t>之前玩過的 API：</a:t>
+            </a:r>
+            <a:br/>
+            <a:r>
+              <a:t>🐕 Dog API → 隨機狗圖</a:t>
+            </a:r>
+            <a:br/>
+            <a:r>
+              <a:t>🐱 Cat API → 隨機貓圖</a:t>
+            </a:r>
+            <a:br/>
+            <a:r>
+              <a:t>🎌 Anime API → 搜尋動漫角色</a:t>
+            </a:r>
+            <a:br/>
+            <a:br/>
+            <a:r>
+              <a:t>LLM API 也一樣！</a:t>
+            </a:r>
+            <a:br/>
+            <a:r>
+              <a:t>📤 輸入：你的問題</a:t>
+            </a:r>
+            <a:br/>
+            <a:r>
+              <a:t>📥 輸出：AI 的回答</a:t>
+            </a:r>
+            <a:br/>
+            <a:br/>
+            <a:r>
+              <a:t>差別：普通 API 回固定格式</a:t>
+            </a:r>
+            <a:br/>
+            <a:r>
+              <a:t>     LLM API 回智慧生成的文字</a:t>
+            </a:r>
+          </a:p>
+        </p:txBody>
+      </p:sp>
+    </p:spTree>
+  </p:cSld>
+  <p:clrMapOvr>
+    <a:masterClrMapping/>
+  </p:clrMapOvr>
+</p:sld>
+</file>
+
+<file path=ppt/slides/slide43.xml><?xml version="1.0" encoding="utf-8"?>
+<p:sld xmlns:a="http://schemas.openxmlformats.org/drawingml/2006/main" xmlns:p="http://schemas.openxmlformats.org/presentationml/2006/main" xmlns:r="http://schemas.openxmlformats.org/officeDocument/2006/relationships">
+  <p:cSld>
+    <p:bg>
+      <p:bgPr>
+        <a:solidFill>
+          <a:srgbClr val="1A1A2E"/>
+        </a:solidFill>
+        <a:effectLst/>
+      </p:bgPr>
+    </p:bg>
+    <p:spTree>
+      <p:nvGrpSpPr>
+        <p:cNvPr id="1" name=""/>
+        <p:cNvGrpSpPr/>
+        <p:nvPr/>
+      </p:nvGrpSpPr>
+      <p:grpSpPr/>
+      <p:sp>
+        <p:nvSpPr>
+          <p:cNvPr id="2" name="TextBox 1"/>
+          <p:cNvSpPr txBox="1"/>
+          <p:nvPr/>
+        </p:nvSpPr>
+        <p:spPr>
+          <a:xfrm>
+            <a:off x="731520" y="365760"/>
+            <a:ext cx="10058400" cy="914400"/>
+          </a:xfrm>
+          <a:prstGeom prst="rect">
+            <a:avLst/>
+          </a:prstGeom>
+          <a:noFill/>
+        </p:spPr>
+        <p:txBody>
+          <a:bodyPr wrap="square">
+            <a:spAutoFit/>
+          </a:bodyPr>
+          <a:lstStyle/>
+          <a:p>
+            <a:pPr algn="l">
+              <a:defRPr sz="3200" b="1">
+                <a:solidFill>
+                  <a:srgbClr val="FFE135"/>
+                </a:solidFill>
+              </a:defRPr>
+            </a:pPr>
+            <a:r>
+              <a:t>體驗 Gemini API</a:t>
+            </a:r>
+          </a:p>
+        </p:txBody>
+      </p:sp>
+    </p:spTree>
+  </p:cSld>
+  <p:clrMapOvr>
+    <a:masterClrMapping/>
+  </p:clrMapOvr>
+</p:sld>
+</file>
+
+<file path=ppt/slides/slide44.xml><?xml version="1.0" encoding="utf-8"?>
+<p:sld xmlns:a="http://schemas.openxmlformats.org/drawingml/2006/main" xmlns:p="http://schemas.openxmlformats.org/presentationml/2006/main" xmlns:r="http://schemas.openxmlformats.org/officeDocument/2006/relationships">
+  <p:cSld>
+    <p:bg>
+      <p:bgPr>
+        <a:solidFill>
+          <a:srgbClr val="1A1A2E"/>
+        </a:solidFill>
+        <a:effectLst/>
+      </p:bgPr>
+    </p:bg>
+    <p:spTree>
+      <p:nvGrpSpPr>
+        <p:cNvPr id="1" name=""/>
+        <p:cNvGrpSpPr/>
+        <p:nvPr/>
+      </p:nvGrpSpPr>
+      <p:grpSpPr/>
+      <p:sp>
+        <p:nvSpPr>
+          <p:cNvPr id="2" name="TextBox 1"/>
+          <p:cNvSpPr txBox="1"/>
+          <p:nvPr/>
+        </p:nvSpPr>
+        <p:spPr>
+          <a:xfrm>
+            <a:off x="731520" y="365760"/>
+            <a:ext cx="10058400" cy="914400"/>
+          </a:xfrm>
+          <a:prstGeom prst="rect">
+            <a:avLst/>
+          </a:prstGeom>
+          <a:noFill/>
+        </p:spPr>
+        <p:txBody>
+          <a:bodyPr wrap="square">
+            <a:spAutoFit/>
+          </a:bodyPr>
+          <a:lstStyle/>
+          <a:p>
+            <a:pPr algn="l">
+              <a:defRPr sz="3200" b="1">
+                <a:solidFill>
+                  <a:srgbClr val="FFE135"/>
+                </a:solidFill>
+              </a:defRPr>
+            </a:pPr>
+            <a:r>
+              <a:t>拿到你的鑰匙 🔑</a:t>
+            </a:r>
+          </a:p>
+        </p:txBody>
+      </p:sp>
+      <p:sp>
+        <p:nvSpPr>
+          <p:cNvPr id="3" name="TextBox 2"/>
+          <p:cNvSpPr txBox="1"/>
+          <p:nvPr/>
+        </p:nvSpPr>
+        <p:spPr>
+          <a:xfrm>
+            <a:off x="731520" y="1371600"/>
+            <a:ext cx="6400800" cy="3657600"/>
+          </a:xfrm>
+          <a:prstGeom prst="rect">
+            <a:avLst/>
+          </a:prstGeom>
+          <a:noFill/>
+        </p:spPr>
+        <p:txBody>
+          <a:bodyPr wrap="square">
+            <a:spAutoFit/>
+          </a:bodyPr>
+          <a:lstStyle/>
+          <a:p>
+            <a:pPr algn="l">
+              <a:spcAft>
+                <a:spcPts val="800"/>
+              </a:spcAft>
+              <a:defRPr sz="2000" b="0">
+                <a:solidFill>
+                  <a:srgbClr val="FFFFFF"/>
+                </a:solidFill>
+              </a:defRPr>
+            </a:pPr>
+            <a:r>
+              <a:t>• API Key 是你的私人鑰匙</a:t>
+            </a:r>
+          </a:p>
+          <a:p>
+            <a:pPr>
+              <a:spcAft>
+                <a:spcPts val="800"/>
+              </a:spcAft>
+              <a:defRPr sz="2000">
+                <a:solidFill>
+                  <a:srgbClr val="FFFFFF"/>
+                </a:solidFill>
+              </a:defRPr>
+            </a:pPr>
+            <a:r>
+              <a:t>• 不要分享給別人</a:t>
+            </a:r>
+          </a:p>
+          <a:p>
+            <a:pPr>
+              <a:spcAft>
+                <a:spcPts val="800"/>
+              </a:spcAft>
+              <a:defRPr sz="2000">
+                <a:solidFill>
+                  <a:srgbClr val="FFFFFF"/>
+                </a:solidFill>
+              </a:defRPr>
+            </a:pPr>
+            <a:r>
+              <a:t>• 不要放在公開的程式碼裡</a:t>
+            </a:r>
+          </a:p>
+        </p:txBody>
+      </p:sp>
+      <p:sp>
+        <p:nvSpPr>
+          <p:cNvPr id="4" name="TextBox 3"/>
+          <p:cNvSpPr txBox="1"/>
+          <p:nvPr/>
+        </p:nvSpPr>
+        <p:spPr>
+          <a:xfrm>
+            <a:off x="731520" y="2606040"/>
+            <a:ext cx="10058400" cy="3657600"/>
+          </a:xfrm>
+          <a:prstGeom prst="rect">
+            <a:avLst/>
+          </a:prstGeom>
+          <a:solidFill>
+            <a:srgbClr val="0D0D0D"/>
+          </a:solidFill>
+        </p:spPr>
+        <p:txBody>
+          <a:bodyPr wrap="square">
+            <a:spAutoFit/>
+          </a:bodyPr>
+          <a:lstStyle/>
+          <a:p>
+            <a:pPr>
+              <a:defRPr sz="1400">
+                <a:solidFill>
+                  <a:srgbClr val="00FF88"/>
+                </a:solidFill>
+                <a:latin typeface="Menlo"/>
+              </a:defRPr>
+            </a:pPr>
+            <a:r>
+              <a:t>⚠️ 重要！</a:t>
+            </a:r>
+            <a:br/>
+            <a:r>
+              <a:t>- API Key 是你的私人鑰匙</a:t>
+            </a:r>
+            <a:br/>
+            <a:r>
+              <a:t>- 不要分享給別人</a:t>
+            </a:r>
+            <a:br/>
+            <a:r>
+              <a:t>- 不要放在公開的程式碼裡</a:t>
+            </a:r>
+          </a:p>
+        </p:txBody>
+      </p:sp>
+    </p:spTree>
+  </p:cSld>
+  <p:clrMapOvr>
+    <a:masterClrMapping/>
+  </p:clrMapOvr>
+</p:sld>
+</file>
+
+<file path=ppt/slides/slide45.xml><?xml version="1.0" encoding="utf-8"?>
+<p:sld xmlns:a="http://schemas.openxmlformats.org/drawingml/2006/main" xmlns:p="http://schemas.openxmlformats.org/presentationml/2006/main" xmlns:r="http://schemas.openxmlformats.org/officeDocument/2006/relationships">
+  <p:cSld>
+    <p:bg>
+      <p:bgPr>
+        <a:solidFill>
+          <a:srgbClr val="1A1A2E"/>
+        </a:solidFill>
+        <a:effectLst/>
+      </p:bgPr>
+    </p:bg>
+    <p:spTree>
+      <p:nvGrpSpPr>
+        <p:cNvPr id="1" name=""/>
+        <p:cNvGrpSpPr/>
+        <p:nvPr/>
+      </p:nvGrpSpPr>
+      <p:grpSpPr/>
+      <p:sp>
+        <p:nvSpPr>
+          <p:cNvPr id="2" name="TextBox 1"/>
+          <p:cNvSpPr txBox="1"/>
+          <p:nvPr/>
+        </p:nvSpPr>
+        <p:spPr>
+          <a:xfrm>
+            <a:off x="731520" y="365760"/>
+            <a:ext cx="10058400" cy="914400"/>
+          </a:xfrm>
+          <a:prstGeom prst="rect">
+            <a:avLst/>
+          </a:prstGeom>
+          <a:noFill/>
+        </p:spPr>
+        <p:txBody>
+          <a:bodyPr wrap="square">
+            <a:spAutoFit/>
+          </a:bodyPr>
+          <a:lstStyle/>
+          <a:p>
+            <a:pPr algn="l">
+              <a:defRPr sz="3200" b="1">
+                <a:solidFill>
+                  <a:srgbClr val="FFE135"/>
+                </a:solidFill>
+              </a:defRPr>
+            </a:pPr>
+            <a:r>
+              <a:t>用指令呼叫 AI</a:t>
+            </a:r>
+          </a:p>
+        </p:txBody>
+      </p:sp>
+      <p:sp>
+        <p:nvSpPr>
+          <p:cNvPr id="3" name="TextBox 2"/>
+          <p:cNvSpPr txBox="1"/>
+          <p:nvPr/>
+        </p:nvSpPr>
+        <p:spPr>
+          <a:xfrm>
+            <a:off x="731520" y="1828800"/>
+            <a:ext cx="10058400" cy="3657600"/>
+          </a:xfrm>
+          <a:prstGeom prst="rect">
+            <a:avLst/>
+          </a:prstGeom>
+          <a:solidFill>
+            <a:srgbClr val="0D0D0D"/>
+          </a:solidFill>
+        </p:spPr>
+        <p:txBody>
+          <a:bodyPr wrap="square">
+            <a:spAutoFit/>
+          </a:bodyPr>
+          <a:lstStyle/>
+          <a:p>
+            <a:pPr>
+              <a:defRPr sz="1400">
+                <a:solidFill>
+                  <a:srgbClr val="00FF88"/>
+                </a:solidFill>
+                <a:latin typeface="Menlo"/>
+              </a:defRPr>
+            </a:pPr>
+            <a:r>
+              <a:t>curl -X POST https://generativelanguage.googleapis.com/v1beta/interactions \</a:t>
+            </a:r>
+            <a:br/>
+            <a:r>
+              <a:t>  -H "x-goog-api-key: 你的API_KEY" \</a:t>
+            </a:r>
+            <a:br/>
+            <a:r>
+              <a:t>  -H "Content-Type: application/json" \</a:t>
+            </a:r>
+            <a:br/>
+            <a:r>
+              <a:t>  -d '{</a:t>
+            </a:r>
+            <a:br/>
+            <a:r>
+              <a:t>    "model": "gemini-2.5-flash",</a:t>
+            </a:r>
+            <a:br/>
+            <a:r>
+              <a:t>    "input": "Hello, how are you?"</a:t>
+            </a:r>
+            <a:br/>
+            <a:r>
+              <a:t>  }'</a:t>
+            </a:r>
+          </a:p>
+        </p:txBody>
+      </p:sp>
+    </p:spTree>
+  </p:cSld>
+  <p:clrMapOvr>
+    <a:masterClrMapping/>
+  </p:clrMapOvr>
+</p:sld>
+</file>
+
+<file path=ppt/slides/slide46.xml><?xml version="1.0" encoding="utf-8"?>
+<p:sld xmlns:a="http://schemas.openxmlformats.org/drawingml/2006/main" xmlns:p="http://schemas.openxmlformats.org/presentationml/2006/main" xmlns:r="http://schemas.openxmlformats.org/officeDocument/2006/relationships">
+  <p:cSld>
+    <p:bg>
+      <p:bgPr>
+        <a:solidFill>
+          <a:srgbClr val="1A1A2E"/>
+        </a:solidFill>
+        <a:effectLst/>
+      </p:bgPr>
+    </p:bg>
+    <p:spTree>
+      <p:nvGrpSpPr>
+        <p:cNvPr id="1" name=""/>
+        <p:cNvGrpSpPr/>
+        <p:nvPr/>
+      </p:nvGrpSpPr>
+      <p:grpSpPr/>
+      <p:sp>
+        <p:nvSpPr>
+          <p:cNvPr id="2" name="TextBox 1"/>
+          <p:cNvSpPr txBox="1"/>
+          <p:nvPr/>
+        </p:nvSpPr>
+        <p:spPr>
+          <a:xfrm>
+            <a:off x="731520" y="365760"/>
+            <a:ext cx="10058400" cy="914400"/>
+          </a:xfrm>
+          <a:prstGeom prst="rect">
+            <a:avLst/>
+          </a:prstGeom>
+          <a:noFill/>
+        </p:spPr>
+        <p:txBody>
+          <a:bodyPr wrap="square">
+            <a:spAutoFit/>
+          </a:bodyPr>
+          <a:lstStyle/>
+          <a:p>
+            <a:pPr algn="l">
+              <a:defRPr sz="3200" b="1">
+                <a:solidFill>
+                  <a:srgbClr val="FFE135"/>
+                </a:solidFill>
+              </a:defRPr>
+            </a:pPr>
+            <a:r>
+              <a:t>保護你的 API Key</a:t>
+            </a:r>
+          </a:p>
+        </p:txBody>
+      </p:sp>
+      <p:sp>
+        <p:nvSpPr>
+          <p:cNvPr id="3" name="TextBox 2"/>
+          <p:cNvSpPr txBox="1"/>
+          <p:nvPr/>
+        </p:nvSpPr>
+        <p:spPr>
+          <a:xfrm>
+            <a:off x="731520" y="1828800"/>
+            <a:ext cx="10058400" cy="3657600"/>
+          </a:xfrm>
+          <a:prstGeom prst="rect">
+            <a:avLst/>
+          </a:prstGeom>
+          <a:solidFill>
+            <a:srgbClr val="0D0D0D"/>
+          </a:solidFill>
+        </p:spPr>
+        <p:txBody>
+          <a:bodyPr wrap="square">
+            <a:spAutoFit/>
+          </a:bodyPr>
+          <a:lstStyle/>
+          <a:p>
+            <a:pPr>
+              <a:defRPr sz="1400">
+                <a:solidFill>
+                  <a:srgbClr val="00FF88"/>
+                </a:solidFill>
+                <a:latin typeface="Menlo"/>
+              </a:defRPr>
+            </a:pPr>
+            <a:r>
+              <a:t>問題：</a:t>
+            </a:r>
+            <a:br/>
+            <a:r>
+              <a:t>如果把 API Key 放在網頁裡...</a:t>
+            </a:r>
+            <a:br/>
+            <a:r>
+              <a:t>❌ 任何人都能看到原始碼</a:t>
+            </a:r>
+            <a:br/>
+            <a:r>
+              <a:t>❌ 任何人都能偷你的 Key</a:t>
+            </a:r>
+            <a:br/>
+            <a:r>
+              <a:t>❌ 你的免費額度會被用光</a:t>
+            </a:r>
+            <a:br/>
+            <a:br/>
+            <a:r>
+              <a:t>解決方案：Cloudflare Worker</a:t>
+            </a:r>
+            <a:br/>
+            <a:r>
+              <a:t>✅ Key 藏在 Worker 裡</a:t>
+            </a:r>
+            <a:br/>
+            <a:r>
+              <a:t>✅ 網頁只知道 Worker 的網址</a:t>
+            </a:r>
+            <a:br/>
+            <a:br/>
+            <a:r>
+              <a:t>[你的網頁] → [Worker] → [Google AI]</a:t>
+            </a:r>
+            <a:br/>
+            <a:r>
+              <a:t>            Key 在這裡</a:t>
+            </a:r>
+          </a:p>
+        </p:txBody>
+      </p:sp>
+    </p:spTree>
+  </p:cSld>
+  <p:clrMapOvr>
+    <a:masterClrMapping/>
+  </p:clrMapOvr>
+</p:sld>
+</file>
+
+<file path=ppt/slides/slide47.xml><?xml version="1.0" encoding="utf-8"?>
+<p:sld xmlns:a="http://schemas.openxmlformats.org/drawingml/2006/main" xmlns:p="http://schemas.openxmlformats.org/presentationml/2006/main" xmlns:r="http://schemas.openxmlformats.org/officeDocument/2006/relationships">
+  <p:cSld>
+    <p:bg>
+      <p:bgPr>
+        <a:solidFill>
+          <a:srgbClr val="1A1A2E"/>
+        </a:solidFill>
+        <a:effectLst/>
+      </p:bgPr>
+    </p:bg>
+    <p:spTree>
+      <p:nvGrpSpPr>
+        <p:cNvPr id="1" name=""/>
+        <p:cNvGrpSpPr/>
+        <p:nvPr/>
+      </p:nvGrpSpPr>
+      <p:grpSpPr/>
+      <p:sp>
+        <p:nvSpPr>
+          <p:cNvPr id="2" name="TextBox 1"/>
+          <p:cNvSpPr txBox="1"/>
+          <p:nvPr/>
+        </p:nvSpPr>
+        <p:spPr>
+          <a:xfrm>
+            <a:off x="731520" y="365760"/>
+            <a:ext cx="10058400" cy="914400"/>
+          </a:xfrm>
+          <a:prstGeom prst="rect">
+            <a:avLst/>
+          </a:prstGeom>
+          <a:noFill/>
+        </p:spPr>
+        <p:txBody>
+          <a:bodyPr wrap="square">
+            <a:spAutoFit/>
+          </a:bodyPr>
+          <a:lstStyle/>
+          <a:p>
+            <a:pPr algn="l">
+              <a:defRPr sz="3200" b="1">
+                <a:solidFill>
+                  <a:srgbClr val="FFE135"/>
+                </a:solidFill>
+              </a:defRPr>
+            </a:pPr>
+            <a:r>
+              <a:t>建立你的 LLM Endpoint</a:t>
+            </a:r>
+          </a:p>
+        </p:txBody>
+      </p:sp>
+    </p:spTree>
+  </p:cSld>
+  <p:clrMapOvr>
+    <a:masterClrMapping/>
+  </p:clrMapOvr>
+</p:sld>
+</file>
+
+<file path=ppt/slides/slide48.xml><?xml version="1.0" encoding="utf-8"?>
+<p:sld xmlns:a="http://schemas.openxmlformats.org/drawingml/2006/main" xmlns:p="http://schemas.openxmlformats.org/presentationml/2006/main" xmlns:r="http://schemas.openxmlformats.org/officeDocument/2006/relationships">
+  <p:cSld>
+    <p:bg>
+      <p:bgPr>
+        <a:solidFill>
+          <a:srgbClr val="1A1A2E"/>
+        </a:solidFill>
+        <a:effectLst/>
+      </p:bgPr>
+    </p:bg>
+    <p:spTree>
+      <p:nvGrpSpPr>
+        <p:cNvPr id="1" name=""/>
+        <p:cNvGrpSpPr/>
+        <p:nvPr/>
+      </p:nvGrpSpPr>
+      <p:grpSpPr/>
+      <p:sp>
+        <p:nvSpPr>
+          <p:cNvPr id="2" name="TextBox 1"/>
+          <p:cNvSpPr txBox="1"/>
+          <p:nvPr/>
+        </p:nvSpPr>
+        <p:spPr>
+          <a:xfrm>
+            <a:off x="731520" y="365760"/>
+            <a:ext cx="10058400" cy="914400"/>
+          </a:xfrm>
+          <a:prstGeom prst="rect">
+            <a:avLst/>
+          </a:prstGeom>
+          <a:noFill/>
+        </p:spPr>
+        <p:txBody>
+          <a:bodyPr wrap="square">
+            <a:spAutoFit/>
+          </a:bodyPr>
+          <a:lstStyle/>
+          <a:p>
+            <a:pPr algn="l">
+              <a:defRPr sz="3200" b="1">
+                <a:solidFill>
+                  <a:srgbClr val="FFE135"/>
+                </a:solidFill>
+              </a:defRPr>
+            </a:pPr>
+            <a:r>
+              <a:t>Worker 代碼</a:t>
+            </a:r>
+          </a:p>
+        </p:txBody>
+      </p:sp>
+      <p:sp>
+        <p:nvSpPr>
+          <p:cNvPr id="3" name="TextBox 2"/>
+          <p:cNvSpPr txBox="1"/>
+          <p:nvPr/>
+        </p:nvSpPr>
+        <p:spPr>
+          <a:xfrm>
+            <a:off x="731520" y="1828800"/>
+            <a:ext cx="10058400" cy="3657600"/>
+          </a:xfrm>
+          <a:prstGeom prst="rect">
+            <a:avLst/>
+          </a:prstGeom>
+          <a:solidFill>
+            <a:srgbClr val="0D0D0D"/>
+          </a:solidFill>
+        </p:spPr>
+        <p:txBody>
+          <a:bodyPr wrap="square">
+            <a:spAutoFit/>
+          </a:bodyPr>
+          <a:lstStyle/>
+          <a:p>
+            <a:pPr>
+              <a:defRPr sz="1400">
+                <a:solidFill>
+                  <a:srgbClr val="00FF88"/>
+                </a:solidFill>
+                <a:latin typeface="Menlo"/>
+              </a:defRPr>
+            </a:pPr>
+            <a:r>
+              <a:t>export default {</a:t>
+            </a:r>
+            <a:br/>
+            <a:r>
+              <a:t>  async fetch(request, env) {</a:t>
+            </a:r>
+            <a:br/>
+            <a:r>
+              <a:t>    if (request.method !== "POST") {</a:t>
+            </a:r>
+            <a:br/>
+            <a:r>
+              <a:t>      return new Response("Use POST", { status: 405 });</a:t>
+            </a:r>
+            <a:br/>
+            <a:r>
+              <a:t>    }</a:t>
+            </a:r>
+            <a:br/>
+            <a:r>
+              <a:t>    const { prompt } = await request.json();</a:t>
+            </a:r>
+            <a:br/>
+            <a:r>
+              <a:t>    const res = await fetch(</a:t>
+            </a:r>
+            <a:br/>
+            <a:r>
+              <a:t>      "https://generativelanguage.googleapis.com/v1beta/interactions",</a:t>
+            </a:r>
+            <a:br/>
+            <a:r>
+              <a:t>      {</a:t>
+            </a:r>
+            <a:br/>
+            <a:r>
+              <a:t>        method: "POST",</a:t>
+            </a:r>
+            <a:br/>
+            <a:r>
+              <a:t>        headers: {</a:t>
+            </a:r>
+            <a:br/>
+            <a:r>
+              <a:t>          "Content-Type": "application/json",</a:t>
+            </a:r>
+            <a:br/>
+            <a:r>
+              <a:t>          "x-goog-api-key": env.GEMINI_API_KEY</a:t>
+            </a:r>
+            <a:br/>
+            <a:r>
+              <a:t>        },</a:t>
+            </a:r>
+            <a:br/>
+            <a:r>
+              <a:t>        body: JSON.stringify({</a:t>
+            </a:r>
+          </a:p>
+        </p:txBody>
+      </p:sp>
+    </p:spTree>
+  </p:cSld>
+  <p:clrMapOvr>
+    <a:masterClrMapping/>
+  </p:clrMapOvr>
+</p:sld>
+</file>
+
+<file path=ppt/slides/slide49.xml><?xml version="1.0" encoding="utf-8"?>
+<p:sld xmlns:a="http://schemas.openxmlformats.org/drawingml/2006/main" xmlns:p="http://schemas.openxmlformats.org/presentationml/2006/main" xmlns:r="http://schemas.openxmlformats.org/officeDocument/2006/relationships">
+  <p:cSld>
+    <p:bg>
+      <p:bgPr>
+        <a:solidFill>
+          <a:srgbClr val="1A1A2E"/>
+        </a:solidFill>
+        <a:effectLst/>
+      </p:bgPr>
+    </p:bg>
+    <p:spTree>
+      <p:nvGrpSpPr>
+        <p:cNvPr id="1" name=""/>
+        <p:cNvGrpSpPr/>
+        <p:nvPr/>
+      </p:nvGrpSpPr>
+      <p:grpSpPr/>
+      <p:sp>
+        <p:nvSpPr>
+          <p:cNvPr id="2" name="TextBox 1"/>
+          <p:cNvSpPr txBox="1"/>
+          <p:nvPr/>
+        </p:nvSpPr>
+        <p:spPr>
+          <a:xfrm>
+            <a:off x="731520" y="365760"/>
+            <a:ext cx="10058400" cy="914400"/>
+          </a:xfrm>
+          <a:prstGeom prst="rect">
+            <a:avLst/>
+          </a:prstGeom>
+          <a:noFill/>
+        </p:spPr>
+        <p:txBody>
+          <a:bodyPr wrap="square">
+            <a:spAutoFit/>
+          </a:bodyPr>
+          <a:lstStyle/>
+          <a:p>
+            <a:pPr algn="l">
+              <a:defRPr sz="3200" b="1">
+                <a:solidFill>
+                  <a:srgbClr val="FFE135"/>
+                </a:solidFill>
+              </a:defRPr>
+            </a:pPr>
+            <a:r>
+              <a:t>把 Key 藏起來</a:t>
             </a:r>
           </a:p>
         </p:txBody>
@@ -10813,6 +12378,190 @@
             </a:pPr>
             <a:r>
               <a:t>• 你已經站在前端 70% 的位置了</a:t>
+            </a:r>
+          </a:p>
+        </p:txBody>
+      </p:sp>
+    </p:spTree>
+  </p:cSld>
+  <p:clrMapOvr>
+    <a:masterClrMapping/>
+  </p:clrMapOvr>
+</p:sld>
+</file>
+
+<file path=ppt/slides/slide50.xml><?xml version="1.0" encoding="utf-8"?>
+<p:sld xmlns:a="http://schemas.openxmlformats.org/drawingml/2006/main" xmlns:p="http://schemas.openxmlformats.org/presentationml/2006/main" xmlns:r="http://schemas.openxmlformats.org/officeDocument/2006/relationships">
+  <p:cSld>
+    <p:bg>
+      <p:bgPr>
+        <a:solidFill>
+          <a:srgbClr val="1A1A2E"/>
+        </a:solidFill>
+        <a:effectLst/>
+      </p:bgPr>
+    </p:bg>
+    <p:spTree>
+      <p:nvGrpSpPr>
+        <p:cNvPr id="1" name=""/>
+        <p:cNvGrpSpPr/>
+        <p:nvPr/>
+      </p:nvGrpSpPr>
+      <p:grpSpPr/>
+      <p:sp>
+        <p:nvSpPr>
+          <p:cNvPr id="2" name="TextBox 1"/>
+          <p:cNvSpPr txBox="1"/>
+          <p:nvPr/>
+        </p:nvSpPr>
+        <p:spPr>
+          <a:xfrm>
+            <a:off x="731520" y="365760"/>
+            <a:ext cx="10058400" cy="914400"/>
+          </a:xfrm>
+          <a:prstGeom prst="rect">
+            <a:avLst/>
+          </a:prstGeom>
+          <a:noFill/>
+        </p:spPr>
+        <p:txBody>
+          <a:bodyPr wrap="square">
+            <a:spAutoFit/>
+          </a:bodyPr>
+          <a:lstStyle/>
+          <a:p>
+            <a:pPr algn="l">
+              <a:defRPr sz="3200" b="1">
+                <a:solidFill>
+                  <a:srgbClr val="FFE135"/>
+                </a:solidFill>
+              </a:defRPr>
+            </a:pPr>
+            <a:r>
+              <a:t>你有了自己的 LLM API</a:t>
+            </a:r>
+          </a:p>
+        </p:txBody>
+      </p:sp>
+      <p:sp>
+        <p:nvSpPr>
+          <p:cNvPr id="3" name="TextBox 2"/>
+          <p:cNvSpPr txBox="1"/>
+          <p:nvPr/>
+        </p:nvSpPr>
+        <p:spPr>
+          <a:xfrm>
+            <a:off x="731520" y="1828800"/>
+            <a:ext cx="10058400" cy="3657600"/>
+          </a:xfrm>
+          <a:prstGeom prst="rect">
+            <a:avLst/>
+          </a:prstGeom>
+          <a:solidFill>
+            <a:srgbClr val="0D0D0D"/>
+          </a:solidFill>
+        </p:spPr>
+        <p:txBody>
+          <a:bodyPr wrap="square">
+            <a:spAutoFit/>
+          </a:bodyPr>
+          <a:lstStyle/>
+          <a:p>
+            <a:pPr>
+              <a:defRPr sz="1400">
+                <a:solidFill>
+                  <a:srgbClr val="00FF88"/>
+                </a:solidFill>
+                <a:latin typeface="Menlo"/>
+              </a:defRPr>
+            </a:pPr>
+            <a:r>
+              <a:t>curl -X POST "https://你的worker.workers.dev" \</a:t>
+            </a:r>
+            <a:br/>
+            <a:r>
+              <a:t>  -H "Content-Type: application/json" \</a:t>
+            </a:r>
+            <a:br/>
+            <a:r>
+              <a:t>  -d '{"prompt":"你好，請自我介紹"}'</a:t>
+            </a:r>
+            <a:br/>
+            <a:r>
+              <a:t>{</a:t>
+            </a:r>
+            <a:br/>
+            <a:r>
+              <a:t>  "ok": true,</a:t>
+            </a:r>
+            <a:br/>
+            <a:r>
+              <a:t>  "text": "你好！我是 Gemini..."</a:t>
+            </a:r>
+            <a:br/>
+            <a:r>
+              <a:t>}</a:t>
+            </a:r>
+          </a:p>
+        </p:txBody>
+      </p:sp>
+    </p:spTree>
+  </p:cSld>
+  <p:clrMapOvr>
+    <a:masterClrMapping/>
+  </p:clrMapOvr>
+</p:sld>
+</file>
+
+<file path=ppt/slides/slide51.xml><?xml version="1.0" encoding="utf-8"?>
+<p:sld xmlns:a="http://schemas.openxmlformats.org/drawingml/2006/main" xmlns:p="http://schemas.openxmlformats.org/presentationml/2006/main" xmlns:r="http://schemas.openxmlformats.org/officeDocument/2006/relationships">
+  <p:cSld>
+    <p:bg>
+      <p:bgPr>
+        <a:solidFill>
+          <a:srgbClr val="441133"/>
+        </a:solidFill>
+        <a:effectLst/>
+      </p:bgPr>
+    </p:bg>
+    <p:spTree>
+      <p:nvGrpSpPr>
+        <p:cNvPr id="1" name=""/>
+        <p:cNvGrpSpPr/>
+        <p:nvPr/>
+      </p:nvGrpSpPr>
+      <p:grpSpPr/>
+      <p:sp>
+        <p:nvSpPr>
+          <p:cNvPr id="2" name="TextBox 1"/>
+          <p:cNvSpPr txBox="1"/>
+          <p:nvPr/>
+        </p:nvSpPr>
+        <p:spPr>
+          <a:xfrm>
+            <a:off x="914400" y="1828800"/>
+            <a:ext cx="10058400" cy="1828800"/>
+          </a:xfrm>
+          <a:prstGeom prst="rect">
+            <a:avLst/>
+          </a:prstGeom>
+          <a:noFill/>
+        </p:spPr>
+        <p:txBody>
+          <a:bodyPr wrap="square">
+            <a:spAutoFit/>
+          </a:bodyPr>
+          <a:lstStyle/>
+          <a:p>
+            <a:pPr algn="ctr">
+              <a:defRPr sz="4000" b="1">
+                <a:solidFill>
+                  <a:srgbClr val="FFE135"/>
+                </a:solidFill>
+              </a:defRPr>
+            </a:pPr>
+            <a:r>
+              <a:t>📝 附錄：Jones 的教學備忘</a:t>
             </a:r>
           </a:p>
         </p:txBody>

</xml_diff>